<commit_message>
Add Decision Courtroom, problem-first incident view, priority dashboard, merged audit log; a11y 100; doc sync
</commit_message>
<xml_diff>
--- a/docs/TrustLens-AI-Deck.pptx
+++ b/docs/TrustLens-AI-Deck.pptx
@@ -4321,7 +4321,7 @@
                 </a:solidFill>
                 <a:latin typeface="Segoe UI"/>
               </a:rPr>
-              <a:t>Next: live Hugging Face inference + SHAP rendering · multi-tenant audit retention · A/B test the Autonomy Dial defaults.</a:t>
+              <a:t>Next: live Hugging Face inference + SHAP rendering · multi-tenant audit retention · forced first-run onboarding.</a:t>
             </a:r>
           </a:p>
           <a:p>
@@ -7769,7 +7769,7 @@
                 </a:solidFill>
                 <a:latin typeface="Segoe UI"/>
               </a:rPr>
-              <a:t>•  Autonomy Dial — per-recommendation: Always Ask Me → Recommend Only → Act &amp; Notify (auto-disabled on high risk).</a:t>
+              <a:t>•  High-Risk Decision Courtroom — Advocate vs Challenger agents debate the SAME evidence; a disagreement meter forces human review on contested cases.</a:t>
             </a:r>
           </a:p>
           <a:p>
@@ -7801,7 +7801,7 @@
                 </a:solidFill>
                 <a:latin typeface="Segoe UI"/>
               </a:rPr>
-              <a:t>•  Accessibility (WCAG 2.1 AA) — Lighthouse 100/100: focus rings, skip link, reduced motion, ARIA.</a:t>
+              <a:t>•  Problem-first framing + Priority-triage browser (risk + impact + aging + confidence).</a:t>
             </a:r>
           </a:p>
           <a:p>
@@ -7817,7 +7817,7 @@
                 </a:solidFill>
                 <a:latin typeface="Segoe UI"/>
               </a:rPr>
-              <a:t>•  Audit CSV export + AI Explainability context on every audit record.</a:t>
+              <a:t>•  Accessibility (WCAG 2.1 AA) — Lighthouse 100/100; merged Audit &amp; Activity Log with CSV export.</a:t>
             </a:r>
           </a:p>
         </p:txBody>

</xml_diff>